<commit_message>
Limit delivery to TEST and report overall human agreement
</commit_message>
<xml_diff>
--- a/presentation.pptx
+++ b/presentation.pptx
@@ -2,24 +2,24 @@
 <file path=ppt/presentation.xml><?xml version="1.0" encoding="utf-8"?>
 <p:presentation xmlns:p="http://schemas.openxmlformats.org/presentationml/2006/main">
   <p:sldMasterIdLst>
-    <p:sldMasterId xmlns:r="http://schemas.openxmlformats.org/officeDocument/2006/relationships" id="2147483648" r:id="R4e02ec260bdf425e"/>
+    <p:sldMasterId xmlns:r="http://schemas.openxmlformats.org/officeDocument/2006/relationships" id="2147483648" r:id="Rfa720059626a45af"/>
   </p:sldMasterIdLst>
   <p:notesMasterIdLst>
-    <p:notesMasterId xmlns:r="http://schemas.openxmlformats.org/officeDocument/2006/relationships" r:id="Rf35c57c4e1614c61"/>
+    <p:notesMasterId xmlns:r="http://schemas.openxmlformats.org/officeDocument/2006/relationships" r:id="R7661873592d14359"/>
   </p:notesMasterIdLst>
   <p:sldIdLst>
-    <p:sldId xmlns:r="http://schemas.openxmlformats.org/officeDocument/2006/relationships" id="256" r:id="Rdb40cf3be1b94d6d"/>
-    <p:sldId xmlns:r="http://schemas.openxmlformats.org/officeDocument/2006/relationships" id="257" r:id="R5f37e414c2d74cab"/>
-    <p:sldId xmlns:r="http://schemas.openxmlformats.org/officeDocument/2006/relationships" id="258" r:id="Raa654c2327244ff1"/>
-    <p:sldId xmlns:r="http://schemas.openxmlformats.org/officeDocument/2006/relationships" id="259" r:id="Rb15309546727437e"/>
-    <p:sldId xmlns:r="http://schemas.openxmlformats.org/officeDocument/2006/relationships" id="260" r:id="R1e25141c46b94816"/>
-    <p:sldId xmlns:r="http://schemas.openxmlformats.org/officeDocument/2006/relationships" id="261" r:id="R4836f9d979904232"/>
-    <p:sldId xmlns:r="http://schemas.openxmlformats.org/officeDocument/2006/relationships" id="262" r:id="R85f78635abf5453a"/>
-    <p:sldId xmlns:r="http://schemas.openxmlformats.org/officeDocument/2006/relationships" id="263" r:id="Rdbbb5a10c1af48a2"/>
-    <p:sldId xmlns:r="http://schemas.openxmlformats.org/officeDocument/2006/relationships" id="264" r:id="R18f16948d7d74647"/>
-    <p:sldId xmlns:r="http://schemas.openxmlformats.org/officeDocument/2006/relationships" id="265" r:id="Re88794e844254493"/>
-    <p:sldId xmlns:r="http://schemas.openxmlformats.org/officeDocument/2006/relationships" id="266" r:id="R02b6eb8d48c54733"/>
-    <p:sldId xmlns:r="http://schemas.openxmlformats.org/officeDocument/2006/relationships" id="267" r:id="R299f5e20f5ed4058"/>
+    <p:sldId xmlns:r="http://schemas.openxmlformats.org/officeDocument/2006/relationships" id="256" r:id="R18d70f8f33cd4590"/>
+    <p:sldId xmlns:r="http://schemas.openxmlformats.org/officeDocument/2006/relationships" id="257" r:id="R16580c3f8af34b64"/>
+    <p:sldId xmlns:r="http://schemas.openxmlformats.org/officeDocument/2006/relationships" id="258" r:id="Rb393c784e1914e6b"/>
+    <p:sldId xmlns:r="http://schemas.openxmlformats.org/officeDocument/2006/relationships" id="259" r:id="R7d3088c617c643ca"/>
+    <p:sldId xmlns:r="http://schemas.openxmlformats.org/officeDocument/2006/relationships" id="260" r:id="Rf3187b0170d04559"/>
+    <p:sldId xmlns:r="http://schemas.openxmlformats.org/officeDocument/2006/relationships" id="261" r:id="R603ecaeee2e94970"/>
+    <p:sldId xmlns:r="http://schemas.openxmlformats.org/officeDocument/2006/relationships" id="262" r:id="R6023e767d2ab48f8"/>
+    <p:sldId xmlns:r="http://schemas.openxmlformats.org/officeDocument/2006/relationships" id="263" r:id="Re5c77e3148e64fa5"/>
+    <p:sldId xmlns:r="http://schemas.openxmlformats.org/officeDocument/2006/relationships" id="264" r:id="Rc06b1a2bc1534548"/>
+    <p:sldId xmlns:r="http://schemas.openxmlformats.org/officeDocument/2006/relationships" id="265" r:id="R0e5c009999664270"/>
+    <p:sldId xmlns:r="http://schemas.openxmlformats.org/officeDocument/2006/relationships" id="266" r:id="R22ec63da19d34555"/>
+    <p:sldId xmlns:r="http://schemas.openxmlformats.org/officeDocument/2006/relationships" id="267" r:id="Re108b7c33b6842ac"/>
   </p:sldIdLst>
   <p:sldSz cx="12192000" cy="6858000"/>
   <p:notesSz cx="6858000" cy="9144000"/>
@@ -453,7 +453,7 @@
           <a:lstStyle xmlns:a="http://schemas.openxmlformats.org/drawingml/2006/main"/>
           <a:p xmlns:a="http://schemas.openxmlformats.org/drawingml/2006/main">
             <a:r>
-              <a:t>English academic draft. User requested blank group, name and matriculation fields. The owner confirms human labels for the 200 DEV / 1,000 TEST cohort and human inter-annotator agreement. No written course-side approval artifact has been inspected.</a:t>
+              <a:t>English academic draft. User requested blank group, name and matriculation fields. The 1,000 TEST records have human labels and overall raw agreement of 91.13%. No written course-side approval artifact has been inspected.</a:t>
             </a:r>
           </a:p>
         </p:txBody>
@@ -928,7 +928,7 @@
           </a:p>
           <a:p xmlns:a="http://schemas.openxmlformats.org/drawingml/2006/main">
             <a:r>
-              <a:t>Approval source: direct user statement in the task, not an independently inspected course document. The owner confirms that the selected 200 DEV / 1,000 TEST records and agreement table are human annotations. Group, name and matriculation fields remain blank for the final cover. Human inter-annotator agreement is not accuracy, and the development pilot is not a formal held-out result. The answer_sample_plan source above fixes the original 1,000-question TEST population and the 100-question draw before any TEST annotation or scoring. All 1,000 TEST labels must pass formal preflight. Only the predetermined 100 questions enter answer generation and judging, with 600 planned variant results. No formal result or measured gain follows from the sampling plan alone.</a:t>
+              <a:t>Approval source: direct user statement in the task, not an independently inspected course document. The 1,000 TEST records have human labels and overall raw agreement of 91.13%. Group, name and matriculation fields remain blank for the final cover. Human inter-annotator agreement is not accuracy, and the development pilot is not a formal held-out result. The answer_sample_plan source above fixes the original 1,000-question TEST population and the 100-question draw before any TEST annotation or scoring. All 1,000 TEST labels must pass formal preflight. Only the predetermined 100 questions enter answer generation and judging, with 600 planned variant results. No formal result or measured gain follows from the sampling plan alone.</a:t>
             </a:r>
           </a:p>
           <a:p xmlns:a="http://schemas.openxmlformats.org/drawingml/2006/main">
@@ -1428,7 +1428,7 @@
           <a:lstStyle xmlns:a="http://schemas.openxmlformats.org/drawingml/2006/main"/>
           <a:p xmlns:a="http://schemas.openxmlformats.org/drawingml/2006/main">
             <a:r>
-              <a:t>Human inter-annotator agreement across the selected 200 DEVELOPMENT and 1,000 TEST records. Origin corrected on 19 October 2026 following the project owner's explicit confirmation that two independent human annotators produced the entire table. Answerability: 1,200 pairs, raw 98.67%, kappa 0.934. Event status: 1,200 pairs, raw 93.58%, kappa 0.892. Relevance: 15,466 pairs, raw 96.59%, kappa 0.940. Numeric values are unchanged. The raw human streams and annotator identities are not bundled; agreement was not recomputed during this correction. See data/ANNOTATION_PROVENANCE.json and results/human_agreement.json. Historical automated receipts do not establish the authorship of these human labels.</a:t>
+              <a:t>Human inter-annotator agreement for 1,000 TEST records. Overall raw agreement: 91.13% (underlying value 0.9113). Per-field agreement, Cohen kappa and weighted kappa are not reported. The earlier broader-cohort table is excluded. See results/human_agreement.json and data/ANNOTATION_PROVENANCE.json. Human agreement is distinct from automatic answer-quality scores.</a:t>
             </a:r>
           </a:p>
         </p:txBody>
@@ -4056,12 +4056,12 @@
   </p:cSld>
   <p:clrMap bg1="lt1" tx1="dk1" bg2="lt2" tx2="dk2" accent1="accent1" accent2="accent2" accent3="accent3" accent4="accent4" accent5="accent5" accent6="accent6" hlink="hlink" folHlink="folHlink"/>
   <p:sldLayoutIdLst>
-    <p:sldLayoutId xmlns:r="http://schemas.openxmlformats.org/officeDocument/2006/relationships" id="2147483649" r:id="R9d7960ae649e4b63"/>
-    <p:sldLayoutId xmlns:r="http://schemas.openxmlformats.org/officeDocument/2006/relationships" id="2147483650" r:id="R60084dcbe70c4b17"/>
-    <p:sldLayoutId xmlns:r="http://schemas.openxmlformats.org/officeDocument/2006/relationships" id="2147483651" r:id="R953e985c9d13449e"/>
-    <p:sldLayoutId xmlns:r="http://schemas.openxmlformats.org/officeDocument/2006/relationships" id="2147483652" r:id="R3911a1b087db4f8e"/>
-    <p:sldLayoutId xmlns:r="http://schemas.openxmlformats.org/officeDocument/2006/relationships" id="2147483653" r:id="R2a13c6fabb804ae1"/>
-    <p:sldLayoutId xmlns:r="http://schemas.openxmlformats.org/officeDocument/2006/relationships" id="2147483654" r:id="R36b96f2967a341ce"/>
+    <p:sldLayoutId xmlns:r="http://schemas.openxmlformats.org/officeDocument/2006/relationships" id="2147483649" r:id="R66e210c6d383473a"/>
+    <p:sldLayoutId xmlns:r="http://schemas.openxmlformats.org/officeDocument/2006/relationships" id="2147483650" r:id="Rf0a44c8f3c1b4074"/>
+    <p:sldLayoutId xmlns:r="http://schemas.openxmlformats.org/officeDocument/2006/relationships" id="2147483651" r:id="Raafe1b58012f44bd"/>
+    <p:sldLayoutId xmlns:r="http://schemas.openxmlformats.org/officeDocument/2006/relationships" id="2147483652" r:id="R88df349ea5c14e0c"/>
+    <p:sldLayoutId xmlns:r="http://schemas.openxmlformats.org/officeDocument/2006/relationships" id="2147483653" r:id="Re31cb0cf589d4e22"/>
+    <p:sldLayoutId xmlns:r="http://schemas.openxmlformats.org/officeDocument/2006/relationships" id="2147483654" r:id="Rb89b73dc3b4942a5"/>
   </p:sldLayoutIdLst>
   <p:txStyles>
     <p:titleStyle>
@@ -6117,7 +6117,7 @@
           <p:cNvPr id="3" name="">
             <a:extLst xmlns:a="http://schemas.openxmlformats.org/drawingml/2006/main">
               <a:ext uri="{FF2B5EF4-FFF2-40B4-BE49-F238E27FC236}">
-                <a16:creationId xmlns:a16="http://schemas.microsoft.com/office/drawing/2014/main" id="{87A11C93-6571-4B68-AE96-543B34A6E680}"/>
+                <a16:creationId xmlns:a16="http://schemas.microsoft.com/office/drawing/2014/main" id="{A4E050B3-1E0E-4F57-9682-DD92C357EAB2}"/>
               </a:ext>
             </a:extLst>
           </p:cNvPr>
@@ -8251,7 +8251,7 @@
           <p:cNvPr id="3" name="">
             <a:extLst xmlns:a="http://schemas.openxmlformats.org/drawingml/2006/main">
               <a:ext uri="{FF2B5EF4-FFF2-40B4-BE49-F238E27FC236}">
-                <a16:creationId xmlns:a16="http://schemas.microsoft.com/office/drawing/2014/main" id="{70543555-9B76-4423-82C1-A64B3B4C4E9A}"/>
+                <a16:creationId xmlns:a16="http://schemas.microsoft.com/office/drawing/2014/main" id="{38A850AD-0E65-4A02-95BD-AC411192FBB0}"/>
               </a:ext>
             </a:extLst>
           </p:cNvPr>
@@ -9576,7 +9576,7 @@
                 <a:ea typeface="Arial"/>
                 <a:cs typeface="Arial"/>
               </a:rPr>
-              <a:t>Human-annotated dataset: 200 DEVELOPMENT and 1,000 TEST questions; two independent human annotators.</a:t>
+              <a:t>Human-annotated dataset: 1,000 TEST questions; two independent human annotators.</a:t>
             </a:r>
           </a:p>
           <a:p xmlns:a="http://schemas.openxmlformats.org/drawingml/2006/main">
@@ -10823,7 +10823,7 @@
           <p:cNvPr id="3" name="">
             <a:extLst xmlns:a="http://schemas.openxmlformats.org/drawingml/2006/main">
               <a:ext uri="{FF2B5EF4-FFF2-40B4-BE49-F238E27FC236}">
-                <a16:creationId xmlns:a16="http://schemas.microsoft.com/office/drawing/2014/main" id="{A006CC80-7F96-4BD3-92A1-F0C53CE5CBD4}"/>
+                <a16:creationId xmlns:a16="http://schemas.microsoft.com/office/drawing/2014/main" id="{DAD5D2AC-94FB-4308-B93E-3A11F4CE2B61}"/>
               </a:ext>
             </a:extLst>
           </p:cNvPr>
@@ -11879,7 +11879,7 @@
           <p:cNvPr id="3" name="">
             <a:extLst xmlns:a="http://schemas.openxmlformats.org/drawingml/2006/main">
               <a:ext uri="{FF2B5EF4-FFF2-40B4-BE49-F238E27FC236}">
-                <a16:creationId xmlns:a16="http://schemas.microsoft.com/office/drawing/2014/main" id="{E9102A40-E202-4C15-9796-2DECB34F7B69}"/>
+                <a16:creationId xmlns:a16="http://schemas.microsoft.com/office/drawing/2014/main" id="{D3F19152-63D9-4CBE-8738-48E62C7C9ED9}"/>
               </a:ext>
             </a:extLst>
           </p:cNvPr>
@@ -13211,7 +13211,7 @@
           <p:cNvPr id="3" name="">
             <a:extLst xmlns:a="http://schemas.openxmlformats.org/drawingml/2006/main">
               <a:ext uri="{FF2B5EF4-FFF2-40B4-BE49-F238E27FC236}">
-                <a16:creationId xmlns:a16="http://schemas.microsoft.com/office/drawing/2014/main" id="{69E41E22-AFDB-4678-B41A-5A8860DAD2B6}"/>
+                <a16:creationId xmlns:a16="http://schemas.microsoft.com/office/drawing/2014/main" id="{B1C9A4A4-3AEA-41B1-9B11-F1254B014A95}"/>
               </a:ext>
             </a:extLst>
           </p:cNvPr>
@@ -15398,7 +15398,7 @@
           <p:cNvPr id="3" name="">
             <a:extLst xmlns:a="http://schemas.openxmlformats.org/drawingml/2006/main">
               <a:ext uri="{FF2B5EF4-FFF2-40B4-BE49-F238E27FC236}">
-                <a16:creationId xmlns:a16="http://schemas.microsoft.com/office/drawing/2014/main" id="{3B3F2DF3-C31E-49D0-94FA-3EF3A5663B6F}"/>
+                <a16:creationId xmlns:a16="http://schemas.microsoft.com/office/drawing/2014/main" id="{CAF83FDB-226E-4DB4-A3BA-067CE905ECC7}"/>
               </a:ext>
             </a:extLst>
           </p:cNvPr>
@@ -15434,7 +15434,7 @@
                           <a:ea typeface="Arial"/>
                           <a:cs typeface="Arial"/>
                         </a:rPr>
-                        <a:t>Field</a:t>
+                        <a:t>Measure</a:t>
                       </a:r>
                     </a:p>
                   </a:txBody>
@@ -15482,7 +15482,7 @@
                           <a:ea typeface="Arial"/>
                           <a:cs typeface="Arial"/>
                         </a:rPr>
-                        <a:t>Judgment pairs</a:t>
+                        <a:t>Scope</a:t>
                       </a:r>
                     </a:p>
                   </a:txBody>
@@ -15524,7 +15524,7 @@
                           <a:ea typeface="Arial"/>
                           <a:cs typeface="Arial"/>
                         </a:rPr>
-                        <a:t>Raw agreement</a:t>
+                        <a:t>Value</a:t>
                       </a:r>
                     </a:p>
                   </a:txBody>
@@ -15566,7 +15566,7 @@
                           <a:ea typeface="Arial"/>
                           <a:cs typeface="Arial"/>
                         </a:rPr>
-                        <a:t>Cohen kappa</a:t>
+                        <a:t>Type</a:t>
                       </a:r>
                     </a:p>
                   </a:txBody>
@@ -15610,7 +15610,7 @@
                           <a:ea typeface="Arial"/>
                           <a:cs typeface="Arial"/>
                         </a:rPr>
-                        <a:t>Answerability</a:t>
+                        <a:t>Overall agreement</a:t>
                       </a:r>
                     </a:p>
                   </a:txBody>
@@ -15652,7 +15652,7 @@
                           <a:ea typeface="Arial"/>
                           <a:cs typeface="Arial"/>
                         </a:rPr>
-                        <a:t>1,200</a:t>
+                        <a:t>1,000 TEST</a:t>
                       </a:r>
                     </a:p>
                   </a:txBody>
@@ -15688,7 +15688,7 @@
                           <a:ea typeface="Arial"/>
                           <a:cs typeface="Arial"/>
                         </a:rPr>
-                        <a:t>98.67%</a:t>
+                        <a:t>91.13%</a:t>
                       </a:r>
                     </a:p>
                   </a:txBody>
@@ -15724,7 +15724,7 @@
                           <a:ea typeface="Arial"/>
                           <a:cs typeface="Arial"/>
                         </a:rPr>
-                        <a:t>0.934</a:t>
+                        <a:t>Raw agreement</a:t>
                       </a:r>
                     </a:p>
                   </a:txBody>
@@ -15762,7 +15762,7 @@
                           <a:ea typeface="Arial"/>
                           <a:cs typeface="Arial"/>
                         </a:rPr>
-                        <a:t>Event status</a:t>
+                        <a:t>Cohen kappa</a:t>
                       </a:r>
                     </a:p>
                   </a:txBody>
@@ -15804,7 +15804,7 @@
                           <a:ea typeface="Arial"/>
                           <a:cs typeface="Arial"/>
                         </a:rPr>
-                        <a:t>1,200</a:t>
+                        <a:t>TEST</a:t>
                       </a:r>
                     </a:p>
                   </a:txBody>
@@ -15840,7 +15840,7 @@
                           <a:ea typeface="Arial"/>
                           <a:cs typeface="Arial"/>
                         </a:rPr>
-                        <a:t>93.58%</a:t>
+                        <a:t>Not reported</a:t>
                       </a:r>
                     </a:p>
                   </a:txBody>
@@ -15876,7 +15876,7 @@
                           <a:ea typeface="Arial"/>
                           <a:cs typeface="Arial"/>
                         </a:rPr>
-                        <a:t>0.892</a:t>
+                        <a:t>-</a:t>
                       </a:r>
                     </a:p>
                   </a:txBody>
@@ -15914,7 +15914,7 @@
                           <a:ea typeface="Arial"/>
                           <a:cs typeface="Arial"/>
                         </a:rPr>
-                        <a:t>Evidence relevance</a:t>
+                        <a:t>Weighted kappa</a:t>
                       </a:r>
                     </a:p>
                   </a:txBody>
@@ -15956,7 +15956,7 @@
                           <a:ea typeface="Arial"/>
                           <a:cs typeface="Arial"/>
                         </a:rPr>
-                        <a:t>15,466</a:t>
+                        <a:t>TEST</a:t>
                       </a:r>
                     </a:p>
                   </a:txBody>
@@ -15992,7 +15992,7 @@
                           <a:ea typeface="Arial"/>
                           <a:cs typeface="Arial"/>
                         </a:rPr>
-                        <a:t>96.59%</a:t>
+                        <a:t>Not reported</a:t>
                       </a:r>
                     </a:p>
                   </a:txBody>
@@ -16028,7 +16028,7 @@
                           <a:ea typeface="Arial"/>
                           <a:cs typeface="Arial"/>
                         </a:rPr>
-                        <a:t>0.940</a:t>
+                        <a:t>-</a:t>
                       </a:r>
                     </a:p>
                   </a:txBody>
@@ -16219,7 +16219,7 @@
                 <a:ea typeface="Arial"/>
                 <a:cs typeface="Arial"/>
               </a:rPr>
-              <a:t>Two independent human annotators; 200 DEV + 1,000 TEST records.</a:t>
+              <a:t>Two independent human annotators; 1,000 TEST records.</a:t>
             </a:r>
           </a:p>
         </p:txBody>
@@ -16388,7 +16388,7 @@
                 <a:ea typeface="Arial"/>
                 <a:cs typeface="Arial"/>
               </a:rPr>
-              <a:t>Origin corrected by the owner; reported agreement values unchanged.</a:t>
+              <a:t>Overall raw agreement across the TEST annotation task.</a:t>
             </a:r>
           </a:p>
         </p:txBody>
@@ -16765,7 +16765,7 @@
           <p:cNvPr id="3" name="Chart">
             <a:extLst xmlns:a="http://schemas.openxmlformats.org/drawingml/2006/main">
               <a:ext uri="{FF2B5EF4-FFF2-40B4-BE49-F238E27FC236}">
-                <a16:creationId xmlns:a16="http://schemas.microsoft.com/office/drawing/2014/main" id="{4CFC8EEC-8804-499A-A569-99D1B81DC161}"/>
+                <a16:creationId xmlns:a16="http://schemas.microsoft.com/office/drawing/2014/main" id="{8BE88D99-FBD2-4A9F-80B2-FF3B5107E0F6}"/>
               </a:ext>
             </a:extLst>
           </p:cNvPr>
@@ -16778,7 +16778,7 @@
         </p:xfrm>
         <a:graphic xmlns:a="http://schemas.openxmlformats.org/drawingml/2006/main">
           <a:graphicData uri="http://schemas.openxmlformats.org/drawingml/2006/chart">
-            <c:chart xmlns:r="http://schemas.openxmlformats.org/officeDocument/2006/relationships" xmlns:c="http://schemas.openxmlformats.org/drawingml/2006/chart" r:id="R483b19392488405e"/>
+            <c:chart xmlns:r="http://schemas.openxmlformats.org/officeDocument/2006/relationships" xmlns:c="http://schemas.openxmlformats.org/drawingml/2006/chart" r:id="R2cb38b6d47aa4d2f"/>
           </a:graphicData>
         </a:graphic>
       </p:graphicFrame>
@@ -16787,7 +16787,7 @@
           <p:cNvPr id="4" name="">
             <a:extLst xmlns:a="http://schemas.openxmlformats.org/drawingml/2006/main">
               <a:ext uri="{FF2B5EF4-FFF2-40B4-BE49-F238E27FC236}">
-                <a16:creationId xmlns:a16="http://schemas.microsoft.com/office/drawing/2014/main" id="{6A0E3738-AA2C-4A28-B3D0-C897919CB174}"/>
+                <a16:creationId xmlns:a16="http://schemas.microsoft.com/office/drawing/2014/main" id="{0B503AD6-A424-4524-B5C4-6908F50BBF83}"/>
               </a:ext>
             </a:extLst>
           </p:cNvPr>
@@ -18305,7 +18305,7 @@
           <p:cNvPr id="4" name="">
             <a:extLst xmlns:a="http://schemas.openxmlformats.org/drawingml/2006/main">
               <a:ext uri="{FF2B5EF4-FFF2-40B4-BE49-F238E27FC236}">
-                <a16:creationId xmlns:a16="http://schemas.microsoft.com/office/drawing/2014/main" id="{4BE4EB73-C0AB-4ECD-8D03-B852380EE3AF}"/>
+                <a16:creationId xmlns:a16="http://schemas.microsoft.com/office/drawing/2014/main" id="{CC9D64DA-ED6E-4C47-8746-757B105B58F2}"/>
               </a:ext>
             </a:extLst>
           </p:cNvPr>

</xml_diff>